<commit_message>
Final Presentation Material Revised
</commit_message>
<xml_diff>
--- a/Final_Presentation_2018-16135_JihoonJun.pptx
+++ b/Final_Presentation_2018-16135_JihoonJun.pptx
@@ -11184,14 +11184,19 @@
             <p:ph type="title"/>
           </p:nvPr>
         </p:nvSpPr>
-        <p:spPr/>
+        <p:spPr>
+          <a:xfrm>
+            <a:off x="838200" y="365125"/>
+            <a:ext cx="11049000" cy="1325563"/>
+          </a:xfrm>
+        </p:spPr>
         <p:txBody>
           <a:bodyPr/>
           <a:lstStyle/>
           <a:p>
             <a:r>
               <a:rPr lang="en-US" dirty="0"/>
-              <a:t>App Demo</a:t>
+              <a:t>App Demo &amp; Development Environment</a:t>
             </a:r>
             <a:endParaRPr lang="en-GB" dirty="0"/>
           </a:p>
@@ -11235,6 +11240,74 @@
           </a:prstGeom>
         </p:spPr>
       </p:pic>
+      <p:sp>
+        <p:nvSpPr>
+          <p:cNvPr id="3" name="Content Placeholder 2">
+            <a:extLst>
+              <a:ext uri="{FF2B5EF4-FFF2-40B4-BE49-F238E27FC236}">
+                <a16:creationId xmlns:a16="http://schemas.microsoft.com/office/drawing/2014/main" id="{090C9A20-F849-69AA-8D38-3C693E621DA6}"/>
+              </a:ext>
+            </a:extLst>
+          </p:cNvPr>
+          <p:cNvSpPr>
+            <a:spLocks noGrp="1"/>
+          </p:cNvSpPr>
+          <p:nvPr>
+            <p:ph idx="1"/>
+          </p:nvPr>
+        </p:nvSpPr>
+        <p:spPr>
+          <a:xfrm>
+            <a:off x="4389120" y="1825625"/>
+            <a:ext cx="7802880" cy="4932622"/>
+          </a:xfrm>
+        </p:spPr>
+        <p:txBody>
+          <a:bodyPr>
+            <a:normAutofit/>
+          </a:bodyPr>
+          <a:lstStyle/>
+          <a:p>
+            <a:r>
+              <a:rPr lang="en-GB" dirty="0"/>
+              <a:t>Development OS: MacOS (Apple Silicon M2)</a:t>
+            </a:r>
+          </a:p>
+          <a:p>
+            <a:r>
+              <a:rPr lang="en-GB" dirty="0"/>
+              <a:t>Development IDE (Language): Android Studio (Java)</a:t>
+            </a:r>
+          </a:p>
+          <a:p>
+            <a:r>
+              <a:rPr lang="en-GB" dirty="0"/>
+              <a:t>Minimum SDK Version: API 26 </a:t>
+            </a:r>
+          </a:p>
+          <a:p>
+            <a:r>
+              <a:rPr lang="en-GB" dirty="0"/>
+              <a:t>Test Device OS Version: Android13 (“Tiramisu”)</a:t>
+            </a:r>
+          </a:p>
+          <a:p>
+            <a:r>
+              <a:rPr lang="en-GB" dirty="0"/>
+              <a:t>Compile SDK Version: API 34</a:t>
+            </a:r>
+          </a:p>
+          <a:p>
+            <a:r>
+              <a:rPr lang="en-GB" dirty="0"/>
+              <a:t>Target SDK Version: API 33</a:t>
+            </a:r>
+          </a:p>
+          <a:p>
+            <a:endParaRPr lang="en-GB" dirty="0"/>
+          </a:p>
+        </p:txBody>
+      </p:sp>
     </p:spTree>
     <p:extLst>
       <p:ext uri="{BB962C8B-B14F-4D97-AF65-F5344CB8AC3E}">

</xml_diff>